<commit_message>
correcao do slide 10
</commit_message>
<xml_diff>
--- a/tcc/apresentacao/Defesa_TCC_evidencias_integradas.pptx
+++ b/tcc/apresentacao/Defesa_TCC_evidencias_integradas.pptx
@@ -377,7 +377,7 @@
             <a:pPr indent="0" algn="r">
               <a:buNone/>
             </a:pPr>
-            <a:fld id="{C3AA9532-8581-4C6E-8569-F45A6984673A}" type="slidenum">
+            <a:fld id="{628E2F15-F5E1-4C49-8F7B-ABC4018217E1}" type="slidenum">
               <a:rPr lang="pt-BR" sz="1400" b="0" u="none" strike="noStrike">
                 <a:solidFill>
                   <a:srgbClr val="000000"/>
@@ -551,7 +551,7 @@
               </a:lnSpc>
               <a:buNone/>
             </a:pPr>
-            <a:fld id="{31DA82A6-FE0B-402B-B309-73239FA3CCCC}" type="slidenum">
+            <a:fld id="{8F4B181E-F36E-4E58-8A8D-1F1884AED99D}" type="slidenum">
               <a:rPr lang="en-US" sz="1200" b="0" u="none" strike="noStrike">
                 <a:solidFill>
                   <a:srgbClr val="000000"/>
@@ -737,7 +737,7 @@
                 <a:uFillTx/>
                 <a:latin typeface="Calibri"/>
               </a:rPr>
-              <a:t> </a:t>
+              <a:t>&lt;data/hora&gt;</a:t>
             </a:r>
             <a:endParaRPr lang="pt-BR" sz="1200" b="0" u="none" strike="noStrike">
               <a:solidFill>
@@ -803,7 +803,7 @@
                 <a:uFillTx/>
                 <a:latin typeface="Times New Roman"/>
               </a:rPr>
-              <a:t> </a:t>
+              <a:t>&lt;rodapé&gt;</a:t>
             </a:r>
             <a:endParaRPr lang="pt-BR" sz="1400" b="0" u="none" strike="noStrike">
               <a:solidFill>
@@ -868,7 +868,7 @@
               </a:lnSpc>
               <a:buNone/>
             </a:pPr>
-            <a:fld id="{FF0B5671-37F0-4CF4-96D6-D924F77BE3C9}" type="slidenum">
+            <a:fld id="{E3361251-F6BC-46D2-979B-3505FB819B01}" type="slidenum">
               <a:rPr lang="en-US" sz="1200" b="0" u="none" strike="noStrike">
                 <a:solidFill>
                   <a:schemeClr val="dk1">
@@ -879,7 +879,7 @@
                 <a:uFillTx/>
                 <a:latin typeface="Calibri"/>
               </a:rPr>
-              <a:t>10</a:t>
+              <a:t>&lt;número&gt;</a:t>
             </a:fld>
             <a:endParaRPr lang="pt-BR" sz="1200" b="0" u="none" strike="noStrike">
               <a:solidFill>
@@ -1577,7 +1577,7 @@
               </a:lnSpc>
               <a:buNone/>
             </a:pPr>
-            <a:fld id="{664D4A11-E630-4F46-B63C-5205989EB0FE}" type="slidenum">
+            <a:fld id="{63B00814-2645-4ADE-AB9A-C2797717922B}" type="slidenum">
               <a:rPr lang="en-US" sz="1200" b="0" u="none" strike="noStrike">
                 <a:solidFill>
                   <a:schemeClr val="dk1">
@@ -2372,7 +2372,7 @@
               </a:lnSpc>
               <a:buNone/>
             </a:pPr>
-            <a:fld id="{E4ADB8B8-46C2-46E2-ADEB-BE6229B8C856}" type="slidenum">
+            <a:fld id="{1289B336-659C-4370-BAAF-C8933A9A8F94}" type="slidenum">
               <a:rPr lang="en-US" sz="1200" b="0" u="none" strike="noStrike">
                 <a:solidFill>
                   <a:schemeClr val="dk1">
@@ -2866,7 +2866,7 @@
                 <a:uFillTx/>
                 <a:latin typeface="Calibri"/>
               </a:rPr>
-              <a:t> </a:t>
+              <a:t>&lt;data/hora&gt;</a:t>
             </a:r>
             <a:endParaRPr lang="pt-BR" sz="1200" b="0" u="none" strike="noStrike">
               <a:solidFill>
@@ -2932,7 +2932,7 @@
                 <a:uFillTx/>
                 <a:latin typeface="Times New Roman"/>
               </a:rPr>
-              <a:t> </a:t>
+              <a:t>&lt;rodapé&gt;</a:t>
             </a:r>
             <a:endParaRPr lang="pt-BR" sz="1400" b="0" u="none" strike="noStrike">
               <a:solidFill>
@@ -2997,7 +2997,7 @@
               </a:lnSpc>
               <a:buNone/>
             </a:pPr>
-            <a:fld id="{DFE1022B-DB5C-420A-A92C-9947B8B11062}" type="slidenum">
+            <a:fld id="{FDFCA121-B57E-4FFF-8DF3-4A3759355ABA}" type="slidenum">
               <a:rPr lang="en-US" sz="1200" b="0" u="none" strike="noStrike">
                 <a:solidFill>
                   <a:schemeClr val="dk1">
@@ -3008,7 +3008,7 @@
                 <a:uFillTx/>
                 <a:latin typeface="Calibri"/>
               </a:rPr>
-              <a:t>10</a:t>
+              <a:t>&lt;número&gt;</a:t>
             </a:fld>
             <a:endParaRPr lang="pt-BR" sz="1200" b="0" u="none" strike="noStrike">
               <a:solidFill>
@@ -3491,7 +3491,7 @@
                 <a:uFillTx/>
                 <a:latin typeface="Calibri"/>
               </a:rPr>
-              <a:t> </a:t>
+              <a:t>&lt;data/hora&gt;</a:t>
             </a:r>
             <a:endParaRPr lang="pt-BR" sz="1200" b="0" u="none" strike="noStrike">
               <a:solidFill>
@@ -3557,7 +3557,7 @@
                 <a:uFillTx/>
                 <a:latin typeface="Times New Roman"/>
               </a:rPr>
-              <a:t> </a:t>
+              <a:t>&lt;rodapé&gt;</a:t>
             </a:r>
             <a:endParaRPr lang="pt-BR" sz="1400" b="0" u="none" strike="noStrike">
               <a:solidFill>
@@ -3622,7 +3622,7 @@
               </a:lnSpc>
               <a:buNone/>
             </a:pPr>
-            <a:fld id="{3525DE7B-BAF7-46F2-971C-A3BE0C222409}" type="slidenum">
+            <a:fld id="{A9FADE7C-E9C6-499E-9AC4-98F04E52256C}" type="slidenum">
               <a:rPr lang="en-US" sz="1200" b="0" u="none" strike="noStrike">
                 <a:solidFill>
                   <a:schemeClr val="dk1">
@@ -3633,7 +3633,7 @@
                 <a:uFillTx/>
                 <a:latin typeface="Calibri"/>
               </a:rPr>
-              <a:t>10</a:t>
+              <a:t>&lt;número&gt;</a:t>
             </a:fld>
             <a:endParaRPr lang="pt-BR" sz="1200" b="0" u="none" strike="noStrike">
               <a:solidFill>
@@ -4116,7 +4116,7 @@
                 <a:uFillTx/>
                 <a:latin typeface="Calibri"/>
               </a:rPr>
-              <a:t> </a:t>
+              <a:t>&lt;data/hora&gt;</a:t>
             </a:r>
             <a:endParaRPr lang="pt-BR" sz="1200" b="0" u="none" strike="noStrike">
               <a:solidFill>
@@ -4182,7 +4182,7 @@
                 <a:uFillTx/>
                 <a:latin typeface="Times New Roman"/>
               </a:rPr>
-              <a:t> </a:t>
+              <a:t>&lt;rodapé&gt;</a:t>
             </a:r>
             <a:endParaRPr lang="pt-BR" sz="1400" b="0" u="none" strike="noStrike">
               <a:solidFill>
@@ -4247,7 +4247,7 @@
               </a:lnSpc>
               <a:buNone/>
             </a:pPr>
-            <a:fld id="{5D2814AF-6CF6-40D6-AB10-8562EE204F63}" type="slidenum">
+            <a:fld id="{EEC1814F-665A-4F90-83F0-101656894E5F}" type="slidenum">
               <a:rPr lang="en-US" sz="1200" b="0" u="none" strike="noStrike">
                 <a:solidFill>
                   <a:schemeClr val="dk1">
@@ -4258,7 +4258,7 @@
                 <a:uFillTx/>
                 <a:latin typeface="Calibri"/>
               </a:rPr>
-              <a:t>10</a:t>
+              <a:t>&lt;número&gt;</a:t>
             </a:fld>
             <a:endParaRPr lang="pt-BR" sz="1200" b="0" u="none" strike="noStrike">
               <a:solidFill>
@@ -4525,7 +4525,7 @@
                 <a:uFillTx/>
                 <a:latin typeface="Calibri"/>
               </a:rPr>
-              <a:t> </a:t>
+              <a:t>&lt;data/hora&gt;</a:t>
             </a:r>
             <a:endParaRPr lang="pt-BR" sz="1200" b="0" u="none" strike="noStrike">
               <a:solidFill>
@@ -4591,7 +4591,7 @@
                 <a:uFillTx/>
                 <a:latin typeface="Times New Roman"/>
               </a:rPr>
-              <a:t> </a:t>
+              <a:t>&lt;rodapé&gt;</a:t>
             </a:r>
             <a:endParaRPr lang="pt-BR" sz="1400" b="0" u="none" strike="noStrike">
               <a:solidFill>
@@ -4656,7 +4656,7 @@
               </a:lnSpc>
               <a:buNone/>
             </a:pPr>
-            <a:fld id="{8712A915-2BC2-4F95-B674-5A1E3905AE0C}" type="slidenum">
+            <a:fld id="{AEA95232-70E1-40DD-8C70-153AD415110C}" type="slidenum">
               <a:rPr lang="en-US" sz="1200" b="0" u="none" strike="noStrike">
                 <a:solidFill>
                   <a:schemeClr val="dk1">
@@ -4667,7 +4667,7 @@
                 <a:uFillTx/>
                 <a:latin typeface="Calibri"/>
               </a:rPr>
-              <a:t>10</a:t>
+              <a:t>&lt;número&gt;</a:t>
             </a:fld>
             <a:endParaRPr lang="pt-BR" sz="1200" b="0" u="none" strike="noStrike">
               <a:solidFill>
@@ -5456,7 +5456,7 @@
                 <a:uFillTx/>
                 <a:latin typeface="Calibri"/>
               </a:rPr>
-              <a:t> </a:t>
+              <a:t>&lt;data/hora&gt;</a:t>
             </a:r>
             <a:endParaRPr lang="pt-BR" sz="1200" b="0" u="none" strike="noStrike">
               <a:solidFill>
@@ -5522,7 +5522,7 @@
                 <a:uFillTx/>
                 <a:latin typeface="Times New Roman"/>
               </a:rPr>
-              <a:t> </a:t>
+              <a:t>&lt;rodapé&gt;</a:t>
             </a:r>
             <a:endParaRPr lang="pt-BR" sz="1400" b="0" u="none" strike="noStrike">
               <a:solidFill>
@@ -5587,7 +5587,7 @@
               </a:lnSpc>
               <a:buNone/>
             </a:pPr>
-            <a:fld id="{2A4AC7BE-C541-4D6A-B38D-D57CC83D3653}" type="slidenum">
+            <a:fld id="{8EBF65A6-19DE-46B8-A870-3ED7663CA386}" type="slidenum">
               <a:rPr lang="en-US" sz="1200" b="0" u="none" strike="noStrike">
                 <a:solidFill>
                   <a:schemeClr val="dk1">
@@ -5598,7 +5598,7 @@
                 <a:uFillTx/>
                 <a:latin typeface="Calibri"/>
               </a:rPr>
-              <a:t>10</a:t>
+              <a:t>&lt;número&gt;</a:t>
             </a:fld>
             <a:endParaRPr lang="pt-BR" sz="1200" b="0" u="none" strike="noStrike">
               <a:solidFill>
@@ -6615,7 +6615,7 @@
                 <a:uFillTx/>
                 <a:latin typeface="Calibri"/>
               </a:rPr>
-              <a:t> </a:t>
+              <a:t>&lt;data/hora&gt;</a:t>
             </a:r>
             <a:endParaRPr lang="pt-BR" sz="1200" b="0" u="none" strike="noStrike">
               <a:solidFill>
@@ -6681,7 +6681,7 @@
                 <a:uFillTx/>
                 <a:latin typeface="Times New Roman"/>
               </a:rPr>
-              <a:t> </a:t>
+              <a:t>&lt;rodapé&gt;</a:t>
             </a:r>
             <a:endParaRPr lang="pt-BR" sz="1400" b="0" u="none" strike="noStrike">
               <a:solidFill>
@@ -6746,7 +6746,7 @@
               </a:lnSpc>
               <a:buNone/>
             </a:pPr>
-            <a:fld id="{3AAEF3A5-EC49-418D-99BF-826F37E8CCE6}" type="slidenum">
+            <a:fld id="{5E6FF2DB-CE2E-4CEE-9A37-2CF5DE8B3B90}" type="slidenum">
               <a:rPr lang="en-US" sz="1200" b="0" u="none" strike="noStrike">
                 <a:solidFill>
                   <a:schemeClr val="dk1">
@@ -6757,7 +6757,7 @@
                 <a:uFillTx/>
                 <a:latin typeface="Calibri"/>
               </a:rPr>
-              <a:t>10</a:t>
+              <a:t>&lt;número&gt;</a:t>
             </a:fld>
             <a:endParaRPr lang="pt-BR" sz="1200" b="0" u="none" strike="noStrike">
               <a:solidFill>
@@ -6934,7 +6934,7 @@
                 <a:uFillTx/>
                 <a:latin typeface="Calibri"/>
               </a:rPr>
-              <a:t> </a:t>
+              <a:t>&lt;data/hora&gt;</a:t>
             </a:r>
             <a:endParaRPr lang="pt-BR" sz="1200" b="0" u="none" strike="noStrike">
               <a:solidFill>
@@ -7000,7 +7000,7 @@
                 <a:uFillTx/>
                 <a:latin typeface="Times New Roman"/>
               </a:rPr>
-              <a:t> </a:t>
+              <a:t>&lt;rodapé&gt;</a:t>
             </a:r>
             <a:endParaRPr lang="pt-BR" sz="1400" b="0" u="none" strike="noStrike">
               <a:solidFill>
@@ -7065,7 +7065,7 @@
               </a:lnSpc>
               <a:buNone/>
             </a:pPr>
-            <a:fld id="{399592CC-2E5F-43E5-923F-709FC532A45C}" type="slidenum">
+            <a:fld id="{C00C3733-2173-4061-84B5-21FE7BAF4175}" type="slidenum">
               <a:rPr lang="en-US" sz="1200" b="0" u="none" strike="noStrike">
                 <a:solidFill>
                   <a:schemeClr val="dk1">
@@ -7076,7 +7076,7 @@
                 <a:uFillTx/>
                 <a:latin typeface="Calibri"/>
               </a:rPr>
-              <a:t>10</a:t>
+              <a:t>&lt;número&gt;</a:t>
             </a:fld>
             <a:endParaRPr lang="pt-BR" sz="1200" b="0" u="none" strike="noStrike">
               <a:solidFill>
@@ -7181,7 +7181,7 @@
                 <a:uFillTx/>
                 <a:latin typeface="Calibri"/>
               </a:rPr>
-              <a:t> </a:t>
+              <a:t>&lt;data/hora&gt;</a:t>
             </a:r>
             <a:endParaRPr lang="pt-BR" sz="1200" b="0" u="none" strike="noStrike">
               <a:solidFill>
@@ -7247,7 +7247,7 @@
                 <a:uFillTx/>
                 <a:latin typeface="Times New Roman"/>
               </a:rPr>
-              <a:t> </a:t>
+              <a:t>&lt;rodapé&gt;</a:t>
             </a:r>
             <a:endParaRPr lang="pt-BR" sz="1400" b="0" u="none" strike="noStrike">
               <a:solidFill>
@@ -7312,7 +7312,7 @@
               </a:lnSpc>
               <a:buNone/>
             </a:pPr>
-            <a:fld id="{557C5C33-C207-427C-9CAA-FA0430005788}" type="slidenum">
+            <a:fld id="{98052249-51A2-4475-9AF3-D1D6456BE010}" type="slidenum">
               <a:rPr lang="en-US" sz="1200" b="0" u="none" strike="noStrike">
                 <a:solidFill>
                   <a:schemeClr val="dk1">
@@ -7323,7 +7323,7 @@
                 <a:uFillTx/>
                 <a:latin typeface="Calibri"/>
               </a:rPr>
-              <a:t>10</a:t>
+              <a:t>&lt;número&gt;</a:t>
             </a:fld>
             <a:endParaRPr lang="pt-BR" sz="1200" b="0" u="none" strike="noStrike">
               <a:solidFill>

</xml_diff>